<commit_message>
docs(P1): PPT 财务口径对齐 SSOT——143万→697.1万 + 35/25/25/15→40/30/20/10
memory 标记的 P1 尾巴"PPT(143万)未动待后续"本次扫平。generate_ppt.py
三处废弃口径全部替换为《财务预测与商业计划》权威数据，重生成路演PPT_V2.pptx；
同时 git rm 零引用的旧版路演PPT.pptx（18页/Aug20/slide16含143万，已被
V2冠军版22页取代，VCS可恢复符合文件保护豁免）。

第21页财务预测表（季度聚合，源自财务预测 3.1/3.2/五章）：
- 废弃 M10-12 累计143.0万/付费1000/月收85万/成本12万/净利73万
- 对齐 M1-3: 150用户/10.9万月收/26.8万累计/3.9万成本/7.0万净利
         M4-6: 600/34.1/110.9/9.5/24.6
         M7-9: 1,500/79.2/308.4/24.8/54.4
         M10-12: 3,000/152.2/**697.1**/42.5/109.7
- 页眉免责声明从"下表为早期保守季度测算"改为"已对齐权威模型，M12累计697.1万"

第22页融资计划资金用途（核心数字基准表 line 42 明确废弃 35/25/25/15）：
- 40%技术研发（7大Agent+AI API+数据对接）/ 30%市场拓展（义乌地推驻点+39城）
  / 20%团队建设（核心工程师+运营/政策）/ 10%运营储备（服务器+法务+应急）

第22页融资后里程碑（对齐财务预测季度聚合值）：
- M1-3 种子用户150+（原50+）/ M4-6 付费600+月收34万（原200+/15万）
  / M7-9 付费1,500+月收79万（原500+）/ M10-12 月收152万累计697万（原85万）

验证：python-pptx 抽查 Slide21 含697.1/152.2无143残留、Slide22 含
40%/30%/20%/10%无35%/25%残留；全仓 grep 143万/35%研发/25%市场推广/
15%运营储备 = 0活跃命中。
</commit_message>
<xml_diff>
--- a/docs/路演PPT_V2.pptx
+++ b/docs/路演PPT_V2.pptx
@@ -27170,7 +27170,7 @@
               </a:defRPr>
             </a:pPr>
             <a:r>
-              <a:t>12个月收入+39城复制，首月即实现正向现金流（营收以《财务预测与商业计划》697万为准，下表为早期保守季度测算）</a:t>
+              <a:t>12个月收入+39城复制，首月即实现正向现金流（已对齐《财务预测与商业计划》权威模型，M12累计营收697.1万）</a:t>
             </a:r>
           </a:p>
         </p:txBody>
@@ -27933,7 +27933,7 @@
               </a:defRPr>
             </a:pPr>
             <a:r>
-              <a:t>50</a:t>
+              <a:t>150</a:t>
             </a:r>
           </a:p>
         </p:txBody>
@@ -28023,7 +28023,7 @@
               </a:defRPr>
             </a:pPr>
             <a:r>
-              <a:t>3.0</a:t>
+              <a:t>10.9</a:t>
             </a:r>
           </a:p>
         </p:txBody>
@@ -28113,7 +28113,7 @@
               </a:defRPr>
             </a:pPr>
             <a:r>
-              <a:t>3.0</a:t>
+              <a:t>26.8</a:t>
             </a:r>
           </a:p>
         </p:txBody>
@@ -28203,7 +28203,7 @@
               </a:defRPr>
             </a:pPr>
             <a:r>
-              <a:t>5.0</a:t>
+              <a:t>3.9</a:t>
             </a:r>
           </a:p>
         </p:txBody>
@@ -28293,7 +28293,7 @@
               </a:defRPr>
             </a:pPr>
             <a:r>
-              <a:t>-2.0</a:t>
+              <a:t>7.0</a:t>
             </a:r>
           </a:p>
         </p:txBody>
@@ -28473,7 +28473,7 @@
               </a:defRPr>
             </a:pPr>
             <a:r>
-              <a:t>200</a:t>
+              <a:t>600</a:t>
             </a:r>
           </a:p>
         </p:txBody>
@@ -28563,7 +28563,7 @@
               </a:defRPr>
             </a:pPr>
             <a:r>
-              <a:t>15.0</a:t>
+              <a:t>34.1</a:t>
             </a:r>
           </a:p>
         </p:txBody>
@@ -28653,7 +28653,7 @@
               </a:defRPr>
             </a:pPr>
             <a:r>
-              <a:t>18.0</a:t>
+              <a:t>110.9</a:t>
             </a:r>
           </a:p>
         </p:txBody>
@@ -28743,7 +28743,7 @@
               </a:defRPr>
             </a:pPr>
             <a:r>
-              <a:t>6.0</a:t>
+              <a:t>9.5</a:t>
             </a:r>
           </a:p>
         </p:txBody>
@@ -28833,7 +28833,7 @@
               </a:defRPr>
             </a:pPr>
             <a:r>
-              <a:t>9.0</a:t>
+              <a:t>24.6</a:t>
             </a:r>
           </a:p>
         </p:txBody>
@@ -29013,7 +29013,7 @@
               </a:defRPr>
             </a:pPr>
             <a:r>
-              <a:t>500</a:t>
+              <a:t>1,500</a:t>
             </a:r>
           </a:p>
         </p:txBody>
@@ -29103,7 +29103,7 @@
               </a:defRPr>
             </a:pPr>
             <a:r>
-              <a:t>40.0</a:t>
+              <a:t>79.2</a:t>
             </a:r>
           </a:p>
         </p:txBody>
@@ -29193,7 +29193,7 @@
               </a:defRPr>
             </a:pPr>
             <a:r>
-              <a:t>58.0</a:t>
+              <a:t>308.4</a:t>
             </a:r>
           </a:p>
         </p:txBody>
@@ -29283,7 +29283,7 @@
               </a:defRPr>
             </a:pPr>
             <a:r>
-              <a:t>8.0</a:t>
+              <a:t>24.8</a:t>
             </a:r>
           </a:p>
         </p:txBody>
@@ -29373,7 +29373,7 @@
               </a:defRPr>
             </a:pPr>
             <a:r>
-              <a:t>32.0</a:t>
+              <a:t>54.4</a:t>
             </a:r>
           </a:p>
         </p:txBody>
@@ -29553,7 +29553,7 @@
               </a:defRPr>
             </a:pPr>
             <a:r>
-              <a:t>1000</a:t>
+              <a:t>3,000</a:t>
             </a:r>
           </a:p>
         </p:txBody>
@@ -29643,7 +29643,7 @@
               </a:defRPr>
             </a:pPr>
             <a:r>
-              <a:t>85.0</a:t>
+              <a:t>152.2</a:t>
             </a:r>
           </a:p>
         </p:txBody>
@@ -29733,7 +29733,7 @@
               </a:defRPr>
             </a:pPr>
             <a:r>
-              <a:t>143.0</a:t>
+              <a:t>697.1</a:t>
             </a:r>
           </a:p>
         </p:txBody>
@@ -29823,7 +29823,7 @@
               </a:defRPr>
             </a:pPr>
             <a:r>
-              <a:t>12.0</a:t>
+              <a:t>42.5</a:t>
             </a:r>
           </a:p>
         </p:txBody>
@@ -29913,7 +29913,7 @@
               </a:defRPr>
             </a:pPr>
             <a:r>
-              <a:t>73.0</a:t>
+              <a:t>109.7</a:t>
             </a:r>
           </a:p>
         </p:txBody>
@@ -32760,7 +32760,7 @@
               </a:defRPr>
             </a:pPr>
             <a:r>
-              <a:t>35%</a:t>
+              <a:t>40%</a:t>
             </a:r>
           </a:p>
         </p:txBody>
@@ -32805,7 +32805,7 @@
               </a:defRPr>
             </a:pPr>
             <a:r>
-              <a:t>产品研发</a:t>
+              <a:t>技术研发</a:t>
             </a:r>
           </a:p>
         </p:txBody>
@@ -32850,7 +32850,7 @@
               </a:defRPr>
             </a:pPr>
             <a:r>
-              <a:t>7大Agent完善 + 政策复制Agent</a:t>
+              <a:t>7大Agent完善 + AI API + 数据对接</a:t>
             </a:r>
           </a:p>
         </p:txBody>
@@ -32895,7 +32895,7 @@
               </a:defRPr>
             </a:pPr>
             <a:r>
-              <a:t>25%</a:t>
+              <a:t>30%</a:t>
             </a:r>
           </a:p>
         </p:txBody>
@@ -32940,7 +32940,7 @@
               </a:defRPr>
             </a:pPr>
             <a:r>
-              <a:t>市场推广</a:t>
+              <a:t>市场拓展</a:t>
             </a:r>
           </a:p>
         </p:txBody>
@@ -32985,7 +32985,7 @@
               </a:defRPr>
             </a:pPr>
             <a:r>
-              <a:t>义乌商户拓展 + 39城复制</a:t>
+              <a:t>义乌地推驻点 + 39城复制</a:t>
             </a:r>
           </a:p>
         </p:txBody>
@@ -33030,7 +33030,7 @@
               </a:defRPr>
             </a:pPr>
             <a:r>
-              <a:t>25%</a:t>
+              <a:t>20%</a:t>
             </a:r>
           </a:p>
         </p:txBody>
@@ -33120,7 +33120,7 @@
               </a:defRPr>
             </a:pPr>
             <a:r>
-              <a:t>核心岗位招聘 + 城市合伙人</a:t>
+              <a:t>核心工程师招聘 + 运营/政策</a:t>
             </a:r>
           </a:p>
         </p:txBody>
@@ -33165,7 +33165,7 @@
               </a:defRPr>
             </a:pPr>
             <a:r>
-              <a:t>15%</a:t>
+              <a:t>10%</a:t>
             </a:r>
           </a:p>
         </p:txBody>
@@ -33255,7 +33255,7 @@
               </a:defRPr>
             </a:pPr>
             <a:r>
-              <a:t>服务器 + 日常运营</a:t>
+              <a:t>服务器 + 法务 + 应急</a:t>
             </a:r>
           </a:p>
         </p:txBody>
@@ -33523,7 +33523,7 @@
               </a:defRPr>
             </a:pPr>
             <a:r>
-              <a:t>义乌本地种子用户50+</a:t>
+              <a:t>义乌本地种子用户150+</a:t>
             </a:r>
           </a:p>
         </p:txBody>
@@ -33656,7 +33656,7 @@
               </a:defRPr>
             </a:pPr>
             <a:r>
-              <a:t>付费用户200+，月收入15万</a:t>
+              <a:t>付费用户600+，月收入34万</a:t>
             </a:r>
           </a:p>
         </p:txBody>
@@ -33834,7 +33834,7 @@
               </a:defRPr>
             </a:pPr>
             <a:r>
-              <a:t>扩大盈利规模，付费用户500+</a:t>
+              <a:t>付费用户1,500+，月收入79万</a:t>
             </a:r>
           </a:p>
         </p:txBody>
@@ -34012,7 +34012,7 @@
               </a:defRPr>
             </a:pPr>
             <a:r>
-              <a:t>月收入85万，准备Pre-A轮</a:t>
+              <a:t>月收入152万，累计营收697万，准备Pre-A轮</a:t>
             </a:r>
           </a:p>
         </p:txBody>

</xml_diff>